<commit_message>
huge progress on video and image slides
</commit_message>
<xml_diff>
--- a/template.pptx
+++ b/template.pptx
@@ -203,7 +203,7 @@
           <a:p>
             <a:fld id="{A65A0C4A-3ED5-0346-BC57-93578252A034}" type="datetimeFigureOut">
               <a:rPr lang="en-BE" smtClean="0"/>
-              <a:t>01/06/2024</a:t>
+              <a:t>09/06/2024</a:t>
             </a:fld>
             <a:endParaRPr lang="en-BE"/>
           </a:p>
@@ -620,6 +620,90 @@
           <a:p>
             <a:fld id="{DEEFEEDD-7AE0-2545-865B-4637248A80C7}" type="slidenum">
               <a:rPr lang="en-BE" smtClean="0"/>
+              <a:t>2</a:t>
+            </a:fld>
+            <a:endParaRPr lang="en-BE"/>
+          </a:p>
+        </p:txBody>
+      </p:sp>
+    </p:spTree>
+    <p:extLst>
+      <p:ext uri="{BB962C8B-B14F-4D97-AF65-F5344CB8AC3E}">
+        <p14:creationId xmlns:p14="http://schemas.microsoft.com/office/powerpoint/2010/main" val="1371867293"/>
+      </p:ext>
+    </p:extLst>
+  </p:cSld>
+  <p:clrMapOvr>
+    <a:masterClrMapping/>
+  </p:clrMapOvr>
+</p:notes>
+</file>
+
+<file path=ppt/notesSlides/notesSlide3.xml><?xml version="1.0" encoding="utf-8"?>
+<p:notes xmlns:a="http://schemas.openxmlformats.org/drawingml/2006/main" xmlns:r="http://schemas.openxmlformats.org/officeDocument/2006/relationships" xmlns:p="http://schemas.openxmlformats.org/presentationml/2006/main">
+  <p:cSld>
+    <p:spTree>
+      <p:nvGrpSpPr>
+        <p:cNvPr id="1" name=""/>
+        <p:cNvGrpSpPr/>
+        <p:nvPr/>
+      </p:nvGrpSpPr>
+      <p:grpSpPr>
+        <a:xfrm>
+          <a:off x="0" y="0"/>
+          <a:ext cx="0" cy="0"/>
+          <a:chOff x="0" y="0"/>
+          <a:chExt cx="0" cy="0"/>
+        </a:xfrm>
+      </p:grpSpPr>
+      <p:sp>
+        <p:nvSpPr>
+          <p:cNvPr id="2" name="Slide Image Placeholder 1"/>
+          <p:cNvSpPr>
+            <a:spLocks noGrp="1" noRot="1" noChangeAspect="1"/>
+          </p:cNvSpPr>
+          <p:nvPr>
+            <p:ph type="sldImg"/>
+          </p:nvPr>
+        </p:nvSpPr>
+        <p:spPr/>
+      </p:sp>
+      <p:sp>
+        <p:nvSpPr>
+          <p:cNvPr id="3" name="Notes Placeholder 2"/>
+          <p:cNvSpPr>
+            <a:spLocks noGrp="1"/>
+          </p:cNvSpPr>
+          <p:nvPr>
+            <p:ph type="body" idx="1"/>
+          </p:nvPr>
+        </p:nvSpPr>
+        <p:spPr/>
+        <p:txBody>
+          <a:bodyPr/>
+          <a:lstStyle/>
+          <a:p>
+            <a:endParaRPr lang="en-BE" dirty="0"/>
+          </a:p>
+        </p:txBody>
+      </p:sp>
+      <p:sp>
+        <p:nvSpPr>
+          <p:cNvPr id="4" name="Slide Number Placeholder 3"/>
+          <p:cNvSpPr>
+            <a:spLocks noGrp="1"/>
+          </p:cNvSpPr>
+          <p:nvPr>
+            <p:ph type="sldNum" sz="quarter" idx="5"/>
+          </p:nvPr>
+        </p:nvSpPr>
+        <p:spPr/>
+        <p:txBody>
+          <a:bodyPr/>
+          <a:lstStyle/>
+          <a:p>
+            <a:fld id="{DEEFEEDD-7AE0-2545-865B-4637248A80C7}" type="slidenum">
+              <a:rPr lang="en-BE" smtClean="0"/>
               <a:t>7</a:t>
             </a:fld>
             <a:endParaRPr lang="en-BE"/>
@@ -788,7 +872,7 @@
           <a:p>
             <a:fld id="{6DF6E040-B977-3E44-A5D5-1DB941796BBD}" type="datetimeFigureOut">
               <a:rPr lang="en-BE" smtClean="0"/>
-              <a:t>01/06/2024</a:t>
+              <a:t>09/06/2024</a:t>
             </a:fld>
             <a:endParaRPr lang="en-BE"/>
           </a:p>
@@ -988,7 +1072,7 @@
           <a:p>
             <a:fld id="{6DF6E040-B977-3E44-A5D5-1DB941796BBD}" type="datetimeFigureOut">
               <a:rPr lang="en-BE" smtClean="0"/>
-              <a:t>01/06/2024</a:t>
+              <a:t>09/06/2024</a:t>
             </a:fld>
             <a:endParaRPr lang="en-BE"/>
           </a:p>
@@ -1198,7 +1282,7 @@
           <a:p>
             <a:fld id="{6DF6E040-B977-3E44-A5D5-1DB941796BBD}" type="datetimeFigureOut">
               <a:rPr lang="en-BE" smtClean="0"/>
-              <a:t>01/06/2024</a:t>
+              <a:t>09/06/2024</a:t>
             </a:fld>
             <a:endParaRPr lang="en-BE"/>
           </a:p>
@@ -1398,7 +1482,7 @@
           <a:p>
             <a:fld id="{6DF6E040-B977-3E44-A5D5-1DB941796BBD}" type="datetimeFigureOut">
               <a:rPr lang="en-BE" smtClean="0"/>
-              <a:t>01/06/2024</a:t>
+              <a:t>09/06/2024</a:t>
             </a:fld>
             <a:endParaRPr lang="en-BE"/>
           </a:p>
@@ -1674,7 +1758,7 @@
           <a:p>
             <a:fld id="{6DF6E040-B977-3E44-A5D5-1DB941796BBD}" type="datetimeFigureOut">
               <a:rPr lang="en-BE" smtClean="0"/>
-              <a:t>01/06/2024</a:t>
+              <a:t>09/06/2024</a:t>
             </a:fld>
             <a:endParaRPr lang="en-BE"/>
           </a:p>
@@ -1942,7 +2026,7 @@
           <a:p>
             <a:fld id="{6DF6E040-B977-3E44-A5D5-1DB941796BBD}" type="datetimeFigureOut">
               <a:rPr lang="en-BE" smtClean="0"/>
-              <a:t>01/06/2024</a:t>
+              <a:t>09/06/2024</a:t>
             </a:fld>
             <a:endParaRPr lang="en-BE"/>
           </a:p>
@@ -2357,7 +2441,7 @@
           <a:p>
             <a:fld id="{6DF6E040-B977-3E44-A5D5-1DB941796BBD}" type="datetimeFigureOut">
               <a:rPr lang="en-BE" smtClean="0"/>
-              <a:t>01/06/2024</a:t>
+              <a:t>09/06/2024</a:t>
             </a:fld>
             <a:endParaRPr lang="en-BE"/>
           </a:p>
@@ -2499,7 +2583,7 @@
           <a:p>
             <a:fld id="{6DF6E040-B977-3E44-A5D5-1DB941796BBD}" type="datetimeFigureOut">
               <a:rPr lang="en-BE" smtClean="0"/>
-              <a:t>01/06/2024</a:t>
+              <a:t>09/06/2024</a:t>
             </a:fld>
             <a:endParaRPr lang="en-BE"/>
           </a:p>
@@ -2612,7 +2696,7 @@
           <a:p>
             <a:fld id="{6DF6E040-B977-3E44-A5D5-1DB941796BBD}" type="datetimeFigureOut">
               <a:rPr lang="en-BE" smtClean="0"/>
-              <a:t>01/06/2024</a:t>
+              <a:t>09/06/2024</a:t>
             </a:fld>
             <a:endParaRPr lang="en-BE"/>
           </a:p>
@@ -2925,7 +3009,7 @@
           <a:p>
             <a:fld id="{6DF6E040-B977-3E44-A5D5-1DB941796BBD}" type="datetimeFigureOut">
               <a:rPr lang="en-BE" smtClean="0"/>
-              <a:t>01/06/2024</a:t>
+              <a:t>09/06/2024</a:t>
             </a:fld>
             <a:endParaRPr lang="en-BE"/>
           </a:p>
@@ -3214,7 +3298,7 @@
           <a:p>
             <a:fld id="{6DF6E040-B977-3E44-A5D5-1DB941796BBD}" type="datetimeFigureOut">
               <a:rPr lang="en-BE" smtClean="0"/>
-              <a:t>01/06/2024</a:t>
+              <a:t>09/06/2024</a:t>
             </a:fld>
             <a:endParaRPr lang="en-BE"/>
           </a:p>
@@ -3466,7 +3550,7 @@
           <a:p>
             <a:fld id="{6DF6E040-B977-3E44-A5D5-1DB941796BBD}" type="datetimeFigureOut">
               <a:rPr lang="en-BE" smtClean="0"/>
-              <a:t>01/06/2024</a:t>
+              <a:t>09/06/2024</a:t>
             </a:fld>
             <a:endParaRPr lang="en-BE"/>
           </a:p>
@@ -4017,8 +4101,8 @@
         </p:nvSpPr>
         <p:spPr>
           <a:xfrm>
-            <a:off x="4195479" y="130649"/>
-            <a:ext cx="3801042" cy="584775"/>
+            <a:off x="4168230" y="130649"/>
+            <a:ext cx="3855543" cy="584775"/>
           </a:xfrm>
           <a:prstGeom prst="rect">
             <a:avLst/>
@@ -4062,7 +4146,7 @@
                 <a:ea typeface="Change" pitchFamily="2" charset="0"/>
                 <a:cs typeface="Modak" pitchFamily="2" charset="77"/>
               </a:rPr>
-              <a:t>Video with caption</a:t>
+              <a:t>Media with caption</a:t>
             </a:r>
           </a:p>
         </p:txBody>

</xml_diff>

<commit_message>
progress and unprogress (insert_logo_slide is broken)
</commit_message>
<xml_diff>
--- a/template.pptx
+++ b/template.pptx
@@ -8,7 +8,7 @@
     <p:notesMasterId r:id="rId9"/>
   </p:notesMasterIdLst>
   <p:sldIdLst>
-    <p:sldId id="256" r:id="rId2"/>
+    <p:sldId id="292" r:id="rId2"/>
     <p:sldId id="273" r:id="rId3"/>
     <p:sldId id="257" r:id="rId4"/>
     <p:sldId id="289" r:id="rId5"/>
@@ -536,90 +536,6 @@
           <a:p>
             <a:fld id="{DEEFEEDD-7AE0-2545-865B-4637248A80C7}" type="slidenum">
               <a:rPr lang="en-BE" smtClean="0"/>
-              <a:t>1</a:t>
-            </a:fld>
-            <a:endParaRPr lang="en-BE"/>
-          </a:p>
-        </p:txBody>
-      </p:sp>
-    </p:spTree>
-    <p:extLst>
-      <p:ext uri="{BB962C8B-B14F-4D97-AF65-F5344CB8AC3E}">
-        <p14:creationId xmlns:p14="http://schemas.microsoft.com/office/powerpoint/2010/main" val="2507593351"/>
-      </p:ext>
-    </p:extLst>
-  </p:cSld>
-  <p:clrMapOvr>
-    <a:masterClrMapping/>
-  </p:clrMapOvr>
-</p:notes>
-</file>
-
-<file path=ppt/notesSlides/notesSlide2.xml><?xml version="1.0" encoding="utf-8"?>
-<p:notes xmlns:a="http://schemas.openxmlformats.org/drawingml/2006/main" xmlns:r="http://schemas.openxmlformats.org/officeDocument/2006/relationships" xmlns:p="http://schemas.openxmlformats.org/presentationml/2006/main">
-  <p:cSld>
-    <p:spTree>
-      <p:nvGrpSpPr>
-        <p:cNvPr id="1" name=""/>
-        <p:cNvGrpSpPr/>
-        <p:nvPr/>
-      </p:nvGrpSpPr>
-      <p:grpSpPr>
-        <a:xfrm>
-          <a:off x="0" y="0"/>
-          <a:ext cx="0" cy="0"/>
-          <a:chOff x="0" y="0"/>
-          <a:chExt cx="0" cy="0"/>
-        </a:xfrm>
-      </p:grpSpPr>
-      <p:sp>
-        <p:nvSpPr>
-          <p:cNvPr id="2" name="Slide Image Placeholder 1"/>
-          <p:cNvSpPr>
-            <a:spLocks noGrp="1" noRot="1" noChangeAspect="1"/>
-          </p:cNvSpPr>
-          <p:nvPr>
-            <p:ph type="sldImg"/>
-          </p:nvPr>
-        </p:nvSpPr>
-        <p:spPr/>
-      </p:sp>
-      <p:sp>
-        <p:nvSpPr>
-          <p:cNvPr id="3" name="Notes Placeholder 2"/>
-          <p:cNvSpPr>
-            <a:spLocks noGrp="1"/>
-          </p:cNvSpPr>
-          <p:nvPr>
-            <p:ph type="body" idx="1"/>
-          </p:nvPr>
-        </p:nvSpPr>
-        <p:spPr/>
-        <p:txBody>
-          <a:bodyPr/>
-          <a:lstStyle/>
-          <a:p>
-            <a:endParaRPr lang="en-BE" dirty="0"/>
-          </a:p>
-        </p:txBody>
-      </p:sp>
-      <p:sp>
-        <p:nvSpPr>
-          <p:cNvPr id="4" name="Slide Number Placeholder 3"/>
-          <p:cNvSpPr>
-            <a:spLocks noGrp="1"/>
-          </p:cNvSpPr>
-          <p:nvPr>
-            <p:ph type="sldNum" sz="quarter" idx="5"/>
-          </p:nvPr>
-        </p:nvSpPr>
-        <p:spPr/>
-        <p:txBody>
-          <a:bodyPr/>
-          <a:lstStyle/>
-          <a:p>
-            <a:fld id="{DEEFEEDD-7AE0-2545-865B-4637248A80C7}" type="slidenum">
-              <a:rPr lang="en-BE" smtClean="0"/>
               <a:t>2</a:t>
             </a:fld>
             <a:endParaRPr lang="en-BE"/>
@@ -639,7 +555,7 @@
 </p:notes>
 </file>
 
-<file path=ppt/notesSlides/notesSlide3.xml><?xml version="1.0" encoding="utf-8"?>
+<file path=ppt/notesSlides/notesSlide2.xml><?xml version="1.0" encoding="utf-8"?>
 <p:notes xmlns:a="http://schemas.openxmlformats.org/drawingml/2006/main" xmlns:r="http://schemas.openxmlformats.org/officeDocument/2006/relationships" xmlns:p="http://schemas.openxmlformats.org/presentationml/2006/main">
   <p:cSld>
     <p:spTree>
@@ -3969,10 +3885,10 @@
       </p:grpSpPr>
       <p:sp>
         <p:nvSpPr>
-          <p:cNvPr id="4" name="ISDA Church Name">
+          <p:cNvPr id="2" name="ISDA Church Name">
             <a:extLst>
               <a:ext uri="{FF2B5EF4-FFF2-40B4-BE49-F238E27FC236}">
-                <a16:creationId xmlns:a16="http://schemas.microsoft.com/office/drawing/2014/main" id="{A17945A1-5369-505B-D269-D8CFA287F510}"/>
+                <a16:creationId xmlns:a16="http://schemas.microsoft.com/office/drawing/2014/main" id="{D74394BE-5824-CEC3-DFF6-C9A1CE07F892}"/>
               </a:ext>
             </a:extLst>
           </p:cNvPr>
@@ -4029,10 +3945,10 @@
       </p:sp>
       <p:pic>
         <p:nvPicPr>
-          <p:cNvPr id="7" name="Logo" descr="A logo with wings and a blue circle&#10;&#10;Description automatically generated">
+          <p:cNvPr id="3" name="Logo" descr="A logo with wings and a blue circle&#10;&#10;Description automatically generated">
             <a:extLst>
               <a:ext uri="{FF2B5EF4-FFF2-40B4-BE49-F238E27FC236}">
-                <a16:creationId xmlns:a16="http://schemas.microsoft.com/office/drawing/2014/main" id="{E58429A5-7890-71A0-4957-CD22745A5AF7}"/>
+                <a16:creationId xmlns:a16="http://schemas.microsoft.com/office/drawing/2014/main" id="{EEC184F2-33E7-E5EB-2E29-311979453635}"/>
               </a:ext>
             </a:extLst>
           </p:cNvPr>
@@ -4042,7 +3958,7 @@
           <p:nvPr/>
         </p:nvPicPr>
         <p:blipFill>
-          <a:blip r:embed="rId3"/>
+          <a:blip r:embed="rId2"/>
           <a:stretch>
             <a:fillRect/>
           </a:stretch>
@@ -4060,7 +3976,7 @@
     </p:spTree>
     <p:extLst>
       <p:ext uri="{BB962C8B-B14F-4D97-AF65-F5344CB8AC3E}">
-        <p14:creationId xmlns:p14="http://schemas.microsoft.com/office/powerpoint/2010/main" val="2779420303"/>
+        <p14:creationId xmlns:p14="http://schemas.microsoft.com/office/powerpoint/2010/main" val="1985050468"/>
       </p:ext>
     </p:extLst>
   </p:cSld>

</xml_diff>

<commit_message>
made it use the db file from SMMS, cuz why should i bother copying the data all the time
</commit_message>
<xml_diff>
--- a/template.pptx
+++ b/template.pptx
@@ -1,6 +1,6 @@
 
 <file path=ppt/presentation.xml><?xml version="1.0" encoding="utf-8"?>
-<p:presentation xmlns:a="http://schemas.openxmlformats.org/drawingml/2006/main" xmlns:r="http://schemas.openxmlformats.org/officeDocument/2006/relationships" xmlns:p="http://schemas.openxmlformats.org/presentationml/2006/main" saveSubsetFonts="1" autoCompressPictures="0">
+<p:presentation xmlns:a="http://schemas.openxmlformats.org/drawingml/2006/main" xmlns:r="http://schemas.openxmlformats.org/officeDocument/2006/relationships" xmlns:p="http://schemas.openxmlformats.org/presentationml/2006/main" embedTrueTypeFonts="1" autoCompressPictures="0">
   <p:sldMasterIdLst>
     <p:sldMasterId id="2147483648" r:id="rId1"/>
   </p:sldMasterIdLst>
@@ -18,6 +18,12 @@
   </p:sldIdLst>
   <p:sldSz cx="12192000" cy="6858000"/>
   <p:notesSz cx="6858000" cy="9144000"/>
+  <p:embeddedFontLst>
+    <p:embeddedFont>
+      <p:font typeface="Loos Normal Medium" panose="020B0604020102020303" pitchFamily="34" charset="77"/>
+      <p:regular r:id="rId10"/>
+    </p:embeddedFont>
+  </p:embeddedFontLst>
   <p:defaultTextStyle>
     <a:defPPr>
       <a:defRPr lang="en-BE"/>
@@ -203,7 +209,7 @@
           <a:p>
             <a:fld id="{A65A0C4A-3ED5-0346-BC57-93578252A034}" type="datetimeFigureOut">
               <a:rPr lang="en-BE" smtClean="0"/>
-              <a:t>09/06/2024</a:t>
+              <a:t>30/08/2024</a:t>
             </a:fld>
             <a:endParaRPr lang="en-BE"/>
           </a:p>
@@ -788,7 +794,7 @@
           <a:p>
             <a:fld id="{6DF6E040-B977-3E44-A5D5-1DB941796BBD}" type="datetimeFigureOut">
               <a:rPr lang="en-BE" smtClean="0"/>
-              <a:t>09/06/2024</a:t>
+              <a:t>30/08/2024</a:t>
             </a:fld>
             <a:endParaRPr lang="en-BE"/>
           </a:p>
@@ -988,7 +994,7 @@
           <a:p>
             <a:fld id="{6DF6E040-B977-3E44-A5D5-1DB941796BBD}" type="datetimeFigureOut">
               <a:rPr lang="en-BE" smtClean="0"/>
-              <a:t>09/06/2024</a:t>
+              <a:t>30/08/2024</a:t>
             </a:fld>
             <a:endParaRPr lang="en-BE"/>
           </a:p>
@@ -1198,7 +1204,7 @@
           <a:p>
             <a:fld id="{6DF6E040-B977-3E44-A5D5-1DB941796BBD}" type="datetimeFigureOut">
               <a:rPr lang="en-BE" smtClean="0"/>
-              <a:t>09/06/2024</a:t>
+              <a:t>30/08/2024</a:t>
             </a:fld>
             <a:endParaRPr lang="en-BE"/>
           </a:p>
@@ -1398,7 +1404,7 @@
           <a:p>
             <a:fld id="{6DF6E040-B977-3E44-A5D5-1DB941796BBD}" type="datetimeFigureOut">
               <a:rPr lang="en-BE" smtClean="0"/>
-              <a:t>09/06/2024</a:t>
+              <a:t>30/08/2024</a:t>
             </a:fld>
             <a:endParaRPr lang="en-BE"/>
           </a:p>
@@ -1674,7 +1680,7 @@
           <a:p>
             <a:fld id="{6DF6E040-B977-3E44-A5D5-1DB941796BBD}" type="datetimeFigureOut">
               <a:rPr lang="en-BE" smtClean="0"/>
-              <a:t>09/06/2024</a:t>
+              <a:t>30/08/2024</a:t>
             </a:fld>
             <a:endParaRPr lang="en-BE"/>
           </a:p>
@@ -1942,7 +1948,7 @@
           <a:p>
             <a:fld id="{6DF6E040-B977-3E44-A5D5-1DB941796BBD}" type="datetimeFigureOut">
               <a:rPr lang="en-BE" smtClean="0"/>
-              <a:t>09/06/2024</a:t>
+              <a:t>30/08/2024</a:t>
             </a:fld>
             <a:endParaRPr lang="en-BE"/>
           </a:p>
@@ -2357,7 +2363,7 @@
           <a:p>
             <a:fld id="{6DF6E040-B977-3E44-A5D5-1DB941796BBD}" type="datetimeFigureOut">
               <a:rPr lang="en-BE" smtClean="0"/>
-              <a:t>09/06/2024</a:t>
+              <a:t>30/08/2024</a:t>
             </a:fld>
             <a:endParaRPr lang="en-BE"/>
           </a:p>
@@ -2499,7 +2505,7 @@
           <a:p>
             <a:fld id="{6DF6E040-B977-3E44-A5D5-1DB941796BBD}" type="datetimeFigureOut">
               <a:rPr lang="en-BE" smtClean="0"/>
-              <a:t>09/06/2024</a:t>
+              <a:t>30/08/2024</a:t>
             </a:fld>
             <a:endParaRPr lang="en-BE"/>
           </a:p>
@@ -2612,7 +2618,7 @@
           <a:p>
             <a:fld id="{6DF6E040-B977-3E44-A5D5-1DB941796BBD}" type="datetimeFigureOut">
               <a:rPr lang="en-BE" smtClean="0"/>
-              <a:t>09/06/2024</a:t>
+              <a:t>30/08/2024</a:t>
             </a:fld>
             <a:endParaRPr lang="en-BE"/>
           </a:p>
@@ -2925,7 +2931,7 @@
           <a:p>
             <a:fld id="{6DF6E040-B977-3E44-A5D5-1DB941796BBD}" type="datetimeFigureOut">
               <a:rPr lang="en-BE" smtClean="0"/>
-              <a:t>09/06/2024</a:t>
+              <a:t>30/08/2024</a:t>
             </a:fld>
             <a:endParaRPr lang="en-BE"/>
           </a:p>
@@ -3214,7 +3220,7 @@
           <a:p>
             <a:fld id="{6DF6E040-B977-3E44-A5D5-1DB941796BBD}" type="datetimeFigureOut">
               <a:rPr lang="en-BE" smtClean="0"/>
-              <a:t>09/06/2024</a:t>
+              <a:t>30/08/2024</a:t>
             </a:fld>
             <a:endParaRPr lang="en-BE"/>
           </a:p>
@@ -3466,7 +3472,7 @@
           <a:p>
             <a:fld id="{6DF6E040-B977-3E44-A5D5-1DB941796BBD}" type="datetimeFigureOut">
               <a:rPr lang="en-BE" smtClean="0"/>
-              <a:t>09/06/2024</a:t>
+              <a:t>30/08/2024</a:t>
             </a:fld>
             <a:endParaRPr lang="en-BE"/>
           </a:p>

</xml_diff>

<commit_message>
removed name from properties
</commit_message>
<xml_diff>
--- a/template.pptx
+++ b/template.pptx
@@ -209,7 +209,7 @@
           <a:p>
             <a:fld id="{A65A0C4A-3ED5-0346-BC57-93578252A034}" type="datetimeFigureOut">
               <a:rPr lang="en-BE" smtClean="0"/>
-              <a:t>30/08/2024</a:t>
+              <a:t>11/3/24</a:t>
             </a:fld>
             <a:endParaRPr lang="en-BE"/>
           </a:p>
@@ -794,7 +794,7 @@
           <a:p>
             <a:fld id="{6DF6E040-B977-3E44-A5D5-1DB941796BBD}" type="datetimeFigureOut">
               <a:rPr lang="en-BE" smtClean="0"/>
-              <a:t>30/08/2024</a:t>
+              <a:t>11/3/24</a:t>
             </a:fld>
             <a:endParaRPr lang="en-BE"/>
           </a:p>
@@ -994,7 +994,7 @@
           <a:p>
             <a:fld id="{6DF6E040-B977-3E44-A5D5-1DB941796BBD}" type="datetimeFigureOut">
               <a:rPr lang="en-BE" smtClean="0"/>
-              <a:t>30/08/2024</a:t>
+              <a:t>11/3/24</a:t>
             </a:fld>
             <a:endParaRPr lang="en-BE"/>
           </a:p>
@@ -1204,7 +1204,7 @@
           <a:p>
             <a:fld id="{6DF6E040-B977-3E44-A5D5-1DB941796BBD}" type="datetimeFigureOut">
               <a:rPr lang="en-BE" smtClean="0"/>
-              <a:t>30/08/2024</a:t>
+              <a:t>11/3/24</a:t>
             </a:fld>
             <a:endParaRPr lang="en-BE"/>
           </a:p>
@@ -1404,7 +1404,7 @@
           <a:p>
             <a:fld id="{6DF6E040-B977-3E44-A5D5-1DB941796BBD}" type="datetimeFigureOut">
               <a:rPr lang="en-BE" smtClean="0"/>
-              <a:t>30/08/2024</a:t>
+              <a:t>11/3/24</a:t>
             </a:fld>
             <a:endParaRPr lang="en-BE"/>
           </a:p>
@@ -1680,7 +1680,7 @@
           <a:p>
             <a:fld id="{6DF6E040-B977-3E44-A5D5-1DB941796BBD}" type="datetimeFigureOut">
               <a:rPr lang="en-BE" smtClean="0"/>
-              <a:t>30/08/2024</a:t>
+              <a:t>11/3/24</a:t>
             </a:fld>
             <a:endParaRPr lang="en-BE"/>
           </a:p>
@@ -1948,7 +1948,7 @@
           <a:p>
             <a:fld id="{6DF6E040-B977-3E44-A5D5-1DB941796BBD}" type="datetimeFigureOut">
               <a:rPr lang="en-BE" smtClean="0"/>
-              <a:t>30/08/2024</a:t>
+              <a:t>11/3/24</a:t>
             </a:fld>
             <a:endParaRPr lang="en-BE"/>
           </a:p>
@@ -2363,7 +2363,7 @@
           <a:p>
             <a:fld id="{6DF6E040-B977-3E44-A5D5-1DB941796BBD}" type="datetimeFigureOut">
               <a:rPr lang="en-BE" smtClean="0"/>
-              <a:t>30/08/2024</a:t>
+              <a:t>11/3/24</a:t>
             </a:fld>
             <a:endParaRPr lang="en-BE"/>
           </a:p>
@@ -2505,7 +2505,7 @@
           <a:p>
             <a:fld id="{6DF6E040-B977-3E44-A5D5-1DB941796BBD}" type="datetimeFigureOut">
               <a:rPr lang="en-BE" smtClean="0"/>
-              <a:t>30/08/2024</a:t>
+              <a:t>11/3/24</a:t>
             </a:fld>
             <a:endParaRPr lang="en-BE"/>
           </a:p>
@@ -2618,7 +2618,7 @@
           <a:p>
             <a:fld id="{6DF6E040-B977-3E44-A5D5-1DB941796BBD}" type="datetimeFigureOut">
               <a:rPr lang="en-BE" smtClean="0"/>
-              <a:t>30/08/2024</a:t>
+              <a:t>11/3/24</a:t>
             </a:fld>
             <a:endParaRPr lang="en-BE"/>
           </a:p>
@@ -2931,7 +2931,7 @@
           <a:p>
             <a:fld id="{6DF6E040-B977-3E44-A5D5-1DB941796BBD}" type="datetimeFigureOut">
               <a:rPr lang="en-BE" smtClean="0"/>
-              <a:t>30/08/2024</a:t>
+              <a:t>11/3/24</a:t>
             </a:fld>
             <a:endParaRPr lang="en-BE"/>
           </a:p>
@@ -3220,7 +3220,7 @@
           <a:p>
             <a:fld id="{6DF6E040-B977-3E44-A5D5-1DB941796BBD}" type="datetimeFigureOut">
               <a:rPr lang="en-BE" smtClean="0"/>
-              <a:t>30/08/2024</a:t>
+              <a:t>11/3/24</a:t>
             </a:fld>
             <a:endParaRPr lang="en-BE"/>
           </a:p>
@@ -3472,7 +3472,7 @@
           <a:p>
             <a:fld id="{6DF6E040-B977-3E44-A5D5-1DB941796BBD}" type="datetimeFigureOut">
               <a:rPr lang="en-BE" smtClean="0"/>
-              <a:t>30/08/2024</a:t>
+              <a:t>11/3/24</a:t>
             </a:fld>
             <a:endParaRPr lang="en-BE"/>
           </a:p>

</xml_diff>

<commit_message>
Small adjustments for better results
</commit_message>
<xml_diff>
--- a/template.pptx
+++ b/template.pptx
@@ -211,7 +211,7 @@
           <a:p>
             <a:fld id="{A65A0C4A-3ED5-0346-BC57-93578252A034}" type="datetimeFigureOut">
               <a:rPr lang="en-BE" smtClean="0"/>
-              <a:t>3/21/25</a:t>
+              <a:t>10/5/25</a:t>
             </a:fld>
             <a:endParaRPr lang="en-BE"/>
           </a:p>
@@ -568,6 +568,90 @@
   <p:cSld>
     <p:spTree>
       <p:nvGrpSpPr>
+        <p:cNvPr id="1" name=""/>
+        <p:cNvGrpSpPr/>
+        <p:nvPr/>
+      </p:nvGrpSpPr>
+      <p:grpSpPr>
+        <a:xfrm>
+          <a:off x="0" y="0"/>
+          <a:ext cx="0" cy="0"/>
+          <a:chOff x="0" y="0"/>
+          <a:chExt cx="0" cy="0"/>
+        </a:xfrm>
+      </p:grpSpPr>
+      <p:sp>
+        <p:nvSpPr>
+          <p:cNvPr id="2" name="Slide Image Placeholder 1"/>
+          <p:cNvSpPr>
+            <a:spLocks noGrp="1" noRot="1" noChangeAspect="1"/>
+          </p:cNvSpPr>
+          <p:nvPr>
+            <p:ph type="sldImg"/>
+          </p:nvPr>
+        </p:nvSpPr>
+        <p:spPr/>
+      </p:sp>
+      <p:sp>
+        <p:nvSpPr>
+          <p:cNvPr id="3" name="Notes Placeholder 2"/>
+          <p:cNvSpPr>
+            <a:spLocks noGrp="1"/>
+          </p:cNvSpPr>
+          <p:nvPr>
+            <p:ph type="body" idx="1"/>
+          </p:nvPr>
+        </p:nvSpPr>
+        <p:spPr/>
+        <p:txBody>
+          <a:bodyPr/>
+          <a:lstStyle/>
+          <a:p>
+            <a:endParaRPr lang="en-US" dirty="0"/>
+          </a:p>
+        </p:txBody>
+      </p:sp>
+      <p:sp>
+        <p:nvSpPr>
+          <p:cNvPr id="4" name="Slide Number Placeholder 3"/>
+          <p:cNvSpPr>
+            <a:spLocks noGrp="1"/>
+          </p:cNvSpPr>
+          <p:nvPr>
+            <p:ph type="sldNum" sz="quarter" idx="5"/>
+          </p:nvPr>
+        </p:nvSpPr>
+        <p:spPr/>
+        <p:txBody>
+          <a:bodyPr/>
+          <a:lstStyle/>
+          <a:p>
+            <a:fld id="{DEEFEEDD-7AE0-2545-865B-4637248A80C7}" type="slidenum">
+              <a:rPr lang="en-BE" smtClean="0"/>
+              <a:t>5</a:t>
+            </a:fld>
+            <a:endParaRPr lang="en-BE"/>
+          </a:p>
+        </p:txBody>
+      </p:sp>
+    </p:spTree>
+    <p:extLst>
+      <p:ext uri="{BB962C8B-B14F-4D97-AF65-F5344CB8AC3E}">
+        <p14:creationId xmlns:p14="http://schemas.microsoft.com/office/powerpoint/2010/main" val="3521456845"/>
+      </p:ext>
+    </p:extLst>
+  </p:cSld>
+  <p:clrMapOvr>
+    <a:masterClrMapping/>
+  </p:clrMapOvr>
+</p:notes>
+</file>
+
+<file path=ppt/notesSlides/notesSlide3.xml><?xml version="1.0" encoding="utf-8"?>
+<p:notes xmlns:a="http://schemas.openxmlformats.org/drawingml/2006/main" xmlns:r="http://schemas.openxmlformats.org/officeDocument/2006/relationships" xmlns:p="http://schemas.openxmlformats.org/presentationml/2006/main">
+  <p:cSld>
+    <p:spTree>
+      <p:nvGrpSpPr>
         <p:cNvPr id="1" name="">
           <a:extLst>
             <a:ext uri="{FF2B5EF4-FFF2-40B4-BE49-F238E27FC236}">
@@ -868,7 +952,7 @@
           <a:p>
             <a:fld id="{6DF6E040-B977-3E44-A5D5-1DB941796BBD}" type="datetimeFigureOut">
               <a:rPr lang="en-BE" smtClean="0"/>
-              <a:t>3/21/25</a:t>
+              <a:t>10/5/25</a:t>
             </a:fld>
             <a:endParaRPr lang="en-BE"/>
           </a:p>
@@ -1038,7 +1122,7 @@
           <a:p>
             <a:fld id="{6DF6E040-B977-3E44-A5D5-1DB941796BBD}" type="datetimeFigureOut">
               <a:rPr lang="en-BE" smtClean="0"/>
-              <a:t>3/21/25</a:t>
+              <a:t>10/5/25</a:t>
             </a:fld>
             <a:endParaRPr lang="en-BE"/>
           </a:p>
@@ -1218,7 +1302,7 @@
           <a:p>
             <a:fld id="{6DF6E040-B977-3E44-A5D5-1DB941796BBD}" type="datetimeFigureOut">
               <a:rPr lang="en-BE" smtClean="0"/>
-              <a:t>3/21/25</a:t>
+              <a:t>10/5/25</a:t>
             </a:fld>
             <a:endParaRPr lang="en-BE"/>
           </a:p>
@@ -1388,7 +1472,7 @@
           <a:p>
             <a:fld id="{6DF6E040-B977-3E44-A5D5-1DB941796BBD}" type="datetimeFigureOut">
               <a:rPr lang="en-BE" smtClean="0"/>
-              <a:t>3/21/25</a:t>
+              <a:t>10/5/25</a:t>
             </a:fld>
             <a:endParaRPr lang="en-BE"/>
           </a:p>
@@ -1634,7 +1718,7 @@
           <a:p>
             <a:fld id="{6DF6E040-B977-3E44-A5D5-1DB941796BBD}" type="datetimeFigureOut">
               <a:rPr lang="en-BE" smtClean="0"/>
-              <a:t>3/21/25</a:t>
+              <a:t>10/5/25</a:t>
             </a:fld>
             <a:endParaRPr lang="en-BE"/>
           </a:p>
@@ -1866,7 +1950,7 @@
           <a:p>
             <a:fld id="{6DF6E040-B977-3E44-A5D5-1DB941796BBD}" type="datetimeFigureOut">
               <a:rPr lang="en-BE" smtClean="0"/>
-              <a:t>3/21/25</a:t>
+              <a:t>10/5/25</a:t>
             </a:fld>
             <a:endParaRPr lang="en-BE"/>
           </a:p>
@@ -2233,7 +2317,7 @@
           <a:p>
             <a:fld id="{6DF6E040-B977-3E44-A5D5-1DB941796BBD}" type="datetimeFigureOut">
               <a:rPr lang="en-BE" smtClean="0"/>
-              <a:t>3/21/25</a:t>
+              <a:t>10/5/25</a:t>
             </a:fld>
             <a:endParaRPr lang="en-BE"/>
           </a:p>
@@ -2351,7 +2435,7 @@
           <a:p>
             <a:fld id="{6DF6E040-B977-3E44-A5D5-1DB941796BBD}" type="datetimeFigureOut">
               <a:rPr lang="en-BE" smtClean="0"/>
-              <a:t>3/21/25</a:t>
+              <a:t>10/5/25</a:t>
             </a:fld>
             <a:endParaRPr lang="en-BE"/>
           </a:p>
@@ -2446,7 +2530,7 @@
           <a:p>
             <a:fld id="{6DF6E040-B977-3E44-A5D5-1DB941796BBD}" type="datetimeFigureOut">
               <a:rPr lang="en-BE" smtClean="0"/>
-              <a:t>3/21/25</a:t>
+              <a:t>10/5/25</a:t>
             </a:fld>
             <a:endParaRPr lang="en-BE"/>
           </a:p>
@@ -2723,7 +2807,7 @@
           <a:p>
             <a:fld id="{6DF6E040-B977-3E44-A5D5-1DB941796BBD}" type="datetimeFigureOut">
               <a:rPr lang="en-BE" smtClean="0"/>
-              <a:t>3/21/25</a:t>
+              <a:t>10/5/25</a:t>
             </a:fld>
             <a:endParaRPr lang="en-BE"/>
           </a:p>
@@ -2980,7 +3064,7 @@
           <a:p>
             <a:fld id="{6DF6E040-B977-3E44-A5D5-1DB941796BBD}" type="datetimeFigureOut">
               <a:rPr lang="en-BE" smtClean="0"/>
-              <a:t>3/21/25</a:t>
+              <a:t>10/5/25</a:t>
             </a:fld>
             <a:endParaRPr lang="en-BE"/>
           </a:p>
@@ -3202,7 +3286,7 @@
           <a:p>
             <a:fld id="{6DF6E040-B977-3E44-A5D5-1DB941796BBD}" type="datetimeFigureOut">
               <a:rPr lang="en-BE" smtClean="0"/>
-              <a:t>3/21/25</a:t>
+              <a:t>10/5/25</a:t>
             </a:fld>
             <a:endParaRPr lang="en-BE"/>
           </a:p>
@@ -4050,8 +4134,8 @@
         </p:nvSpPr>
         <p:spPr>
           <a:xfrm>
-            <a:off x="554182" y="0"/>
-            <a:ext cx="11083636" cy="6858000"/>
+            <a:off x="457200" y="0"/>
+            <a:ext cx="11277600" cy="6858000"/>
           </a:xfrm>
           <a:prstGeom prst="rect">
             <a:avLst/>
@@ -4169,18 +4253,7 @@
                 <a:ea typeface="Change" pitchFamily="2" charset="0"/>
                 <a:cs typeface="Modak" pitchFamily="2" charset="77"/>
               </a:rPr>
-              <a:t>The wonders of Your mighty </a:t>
-            </a:r>
-            <a:r>
-              <a:rPr lang="en-GB" sz="4400" b="1" dirty="0">
-                <a:solidFill>
-                  <a:schemeClr val="bg1"/>
-                </a:solidFill>
-                <a:latin typeface="Nunito ExtraBold" pitchFamily="2" charset="77"/>
-                <a:ea typeface="Change" pitchFamily="2" charset="0"/>
-                <a:cs typeface="Modak" pitchFamily="2" charset="77"/>
-              </a:rPr>
-              <a:t>love</a:t>
+              <a:t>The wonders of Your mighty love</a:t>
             </a:r>
           </a:p>
         </p:txBody>

</xml_diff>

<commit_message>
updated template and formatted code
</commit_message>
<xml_diff>
--- a/template.pptx
+++ b/template.pptx
@@ -211,7 +211,7 @@
           <a:p>
             <a:fld id="{A65A0C4A-3ED5-0346-BC57-93578252A034}" type="datetimeFigureOut">
               <a:rPr lang="en-BE" smtClean="0"/>
-              <a:t>10/5/25</a:t>
+              <a:t>12/19/25</a:t>
             </a:fld>
             <a:endParaRPr lang="en-BE"/>
           </a:p>
@@ -952,7 +952,7 @@
           <a:p>
             <a:fld id="{6DF6E040-B977-3E44-A5D5-1DB941796BBD}" type="datetimeFigureOut">
               <a:rPr lang="en-BE" smtClean="0"/>
-              <a:t>10/5/25</a:t>
+              <a:t>12/19/25</a:t>
             </a:fld>
             <a:endParaRPr lang="en-BE"/>
           </a:p>
@@ -1122,7 +1122,7 @@
           <a:p>
             <a:fld id="{6DF6E040-B977-3E44-A5D5-1DB941796BBD}" type="datetimeFigureOut">
               <a:rPr lang="en-BE" smtClean="0"/>
-              <a:t>10/5/25</a:t>
+              <a:t>12/19/25</a:t>
             </a:fld>
             <a:endParaRPr lang="en-BE"/>
           </a:p>
@@ -1302,7 +1302,7 @@
           <a:p>
             <a:fld id="{6DF6E040-B977-3E44-A5D5-1DB941796BBD}" type="datetimeFigureOut">
               <a:rPr lang="en-BE" smtClean="0"/>
-              <a:t>10/5/25</a:t>
+              <a:t>12/19/25</a:t>
             </a:fld>
             <a:endParaRPr lang="en-BE"/>
           </a:p>
@@ -1472,7 +1472,7 @@
           <a:p>
             <a:fld id="{6DF6E040-B977-3E44-A5D5-1DB941796BBD}" type="datetimeFigureOut">
               <a:rPr lang="en-BE" smtClean="0"/>
-              <a:t>10/5/25</a:t>
+              <a:t>12/19/25</a:t>
             </a:fld>
             <a:endParaRPr lang="en-BE"/>
           </a:p>
@@ -1718,7 +1718,7 @@
           <a:p>
             <a:fld id="{6DF6E040-B977-3E44-A5D5-1DB941796BBD}" type="datetimeFigureOut">
               <a:rPr lang="en-BE" smtClean="0"/>
-              <a:t>10/5/25</a:t>
+              <a:t>12/19/25</a:t>
             </a:fld>
             <a:endParaRPr lang="en-BE"/>
           </a:p>
@@ -1950,7 +1950,7 @@
           <a:p>
             <a:fld id="{6DF6E040-B977-3E44-A5D5-1DB941796BBD}" type="datetimeFigureOut">
               <a:rPr lang="en-BE" smtClean="0"/>
-              <a:t>10/5/25</a:t>
+              <a:t>12/19/25</a:t>
             </a:fld>
             <a:endParaRPr lang="en-BE"/>
           </a:p>
@@ -2317,7 +2317,7 @@
           <a:p>
             <a:fld id="{6DF6E040-B977-3E44-A5D5-1DB941796BBD}" type="datetimeFigureOut">
               <a:rPr lang="en-BE" smtClean="0"/>
-              <a:t>10/5/25</a:t>
+              <a:t>12/19/25</a:t>
             </a:fld>
             <a:endParaRPr lang="en-BE"/>
           </a:p>
@@ -2435,7 +2435,7 @@
           <a:p>
             <a:fld id="{6DF6E040-B977-3E44-A5D5-1DB941796BBD}" type="datetimeFigureOut">
               <a:rPr lang="en-BE" smtClean="0"/>
-              <a:t>10/5/25</a:t>
+              <a:t>12/19/25</a:t>
             </a:fld>
             <a:endParaRPr lang="en-BE"/>
           </a:p>
@@ -2530,7 +2530,7 @@
           <a:p>
             <a:fld id="{6DF6E040-B977-3E44-A5D5-1DB941796BBD}" type="datetimeFigureOut">
               <a:rPr lang="en-BE" smtClean="0"/>
-              <a:t>10/5/25</a:t>
+              <a:t>12/19/25</a:t>
             </a:fld>
             <a:endParaRPr lang="en-BE"/>
           </a:p>
@@ -2807,7 +2807,7 @@
           <a:p>
             <a:fld id="{6DF6E040-B977-3E44-A5D5-1DB941796BBD}" type="datetimeFigureOut">
               <a:rPr lang="en-BE" smtClean="0"/>
-              <a:t>10/5/25</a:t>
+              <a:t>12/19/25</a:t>
             </a:fld>
             <a:endParaRPr lang="en-BE"/>
           </a:p>
@@ -3064,7 +3064,7 @@
           <a:p>
             <a:fld id="{6DF6E040-B977-3E44-A5D5-1DB941796BBD}" type="datetimeFigureOut">
               <a:rPr lang="en-BE" smtClean="0"/>
-              <a:t>10/5/25</a:t>
+              <a:t>12/19/25</a:t>
             </a:fld>
             <a:endParaRPr lang="en-BE"/>
           </a:p>
@@ -3286,7 +3286,7 @@
           <a:p>
             <a:fld id="{6DF6E040-B977-3E44-A5D5-1DB941796BBD}" type="datetimeFigureOut">
               <a:rPr lang="en-BE" smtClean="0"/>
-              <a:t>10/5/25</a:t>
+              <a:t>12/19/25</a:t>
             </a:fld>
             <a:endParaRPr lang="en-BE"/>
           </a:p>

</xml_diff>

<commit_message>
changes to package management and template
</commit_message>
<xml_diff>
--- a/template.pptx
+++ b/template.pptx
@@ -5,25 +5,26 @@
     <p:sldMasterId id="2147483660" r:id="rId1"/>
   </p:sldMasterIdLst>
   <p:notesMasterIdLst>
-    <p:notesMasterId r:id="rId9"/>
+    <p:notesMasterId r:id="rId10"/>
   </p:notesMasterIdLst>
   <p:sldIdLst>
-    <p:sldId id="292" r:id="rId2"/>
+    <p:sldId id="7888" r:id="rId2"/>
     <p:sldId id="273" r:id="rId3"/>
     <p:sldId id="257" r:id="rId4"/>
-    <p:sldId id="289" r:id="rId5"/>
-    <p:sldId id="259" r:id="rId6"/>
-    <p:sldId id="290" r:id="rId7"/>
-    <p:sldId id="7780" r:id="rId8"/>
+    <p:sldId id="7924" r:id="rId5"/>
+    <p:sldId id="289" r:id="rId6"/>
+    <p:sldId id="259" r:id="rId7"/>
+    <p:sldId id="290" r:id="rId8"/>
+    <p:sldId id="7780" r:id="rId9"/>
   </p:sldIdLst>
   <p:sldSz cx="12192000" cy="6858000"/>
   <p:notesSz cx="6858000" cy="9144000"/>
   <p:embeddedFontLst>
     <p:embeddedFont>
       <p:font typeface="Nunito ExtraBold" pitchFamily="2" charset="77"/>
-      <p:bold r:id="rId10"/>
-      <p:italic r:id="rId11"/>
-      <p:boldItalic r:id="rId12"/>
+      <p:bold r:id="rId11"/>
+      <p:italic r:id="rId12"/>
+      <p:boldItalic r:id="rId13"/>
     </p:embeddedFont>
   </p:embeddedFontLst>
   <p:defaultTextStyle>
@@ -211,7 +212,7 @@
           <a:p>
             <a:fld id="{A65A0C4A-3ED5-0346-BC57-93578252A034}" type="datetimeFigureOut">
               <a:rPr lang="en-BE" smtClean="0"/>
-              <a:t>12/19/25</a:t>
+              <a:t>4/4/26</a:t>
             </a:fld>
             <a:endParaRPr lang="en-BE"/>
           </a:p>
@@ -523,6 +524,173 @@
           <a:bodyPr/>
           <a:lstStyle/>
           <a:p>
+            <a:pPr marL="0" marR="0" lvl="0" indent="0" algn="l" defTabSz="914400" rtl="0" eaLnBrk="1" fontAlgn="auto" latinLnBrk="0" hangingPunct="1">
+              <a:lnSpc>
+                <a:spcPct val="100000"/>
+              </a:lnSpc>
+              <a:spcBef>
+                <a:spcPts val="0"/>
+              </a:spcBef>
+              <a:spcAft>
+                <a:spcPts val="0"/>
+              </a:spcAft>
+              <a:buClrTx/>
+              <a:buSzTx/>
+              <a:buFontTx/>
+              <a:buNone/>
+              <a:tabLst/>
+              <a:defRPr/>
+            </a:pPr>
+            <a:endParaRPr lang="en-US" dirty="0"/>
+          </a:p>
+        </p:txBody>
+      </p:sp>
+      <p:sp>
+        <p:nvSpPr>
+          <p:cNvPr id="4" name="Slide Number Placeholder 3"/>
+          <p:cNvSpPr>
+            <a:spLocks noGrp="1"/>
+          </p:cNvSpPr>
+          <p:nvPr>
+            <p:ph type="sldNum" idx="12"/>
+          </p:nvPr>
+        </p:nvSpPr>
+        <p:spPr/>
+        <p:txBody>
+          <a:bodyPr/>
+          <a:lstStyle/>
+          <a:p>
+            <a:pPr marL="0" marR="0" lvl="0" indent="0" algn="r" defTabSz="914400" rtl="0" eaLnBrk="1" fontAlgn="auto" latinLnBrk="0" hangingPunct="1">
+              <a:lnSpc>
+                <a:spcPct val="100000"/>
+              </a:lnSpc>
+              <a:spcBef>
+                <a:spcPts val="0"/>
+              </a:spcBef>
+              <a:spcAft>
+                <a:spcPts val="0"/>
+              </a:spcAft>
+              <a:buClr>
+                <a:srgbClr val="000000"/>
+              </a:buClr>
+              <a:buSzPts val="1200"/>
+              <a:buFont typeface="Arial"/>
+              <a:buNone/>
+              <a:tabLst/>
+              <a:defRPr/>
+            </a:pPr>
+            <a:fld id="{00000000-1234-1234-1234-123412341234}" type="slidenum">
+              <a:rPr kumimoji="0" lang="en-GB" sz="1200" b="0" i="0" u="none" strike="noStrike" kern="0" cap="none" spc="0" normalizeH="0" baseline="0" noProof="0" smtClean="0">
+                <a:ln>
+                  <a:noFill/>
+                </a:ln>
+                <a:solidFill>
+                  <a:srgbClr val="000000"/>
+                </a:solidFill>
+                <a:effectLst/>
+                <a:uLnTx/>
+                <a:uFillTx/>
+                <a:latin typeface="Calibri"/>
+                <a:ea typeface="Calibri"/>
+                <a:cs typeface="Calibri"/>
+                <a:sym typeface="Calibri"/>
+              </a:rPr>
+              <a:pPr marL="0" marR="0" lvl="0" indent="0" algn="r" defTabSz="914400" rtl="0" eaLnBrk="1" fontAlgn="auto" latinLnBrk="0" hangingPunct="1">
+                <a:lnSpc>
+                  <a:spcPct val="100000"/>
+                </a:lnSpc>
+                <a:spcBef>
+                  <a:spcPts val="0"/>
+                </a:spcBef>
+                <a:spcAft>
+                  <a:spcPts val="0"/>
+                </a:spcAft>
+                <a:buClr>
+                  <a:srgbClr val="000000"/>
+                </a:buClr>
+                <a:buSzPts val="1200"/>
+                <a:buFont typeface="Arial"/>
+                <a:buNone/>
+                <a:tabLst/>
+                <a:defRPr/>
+              </a:pPr>
+              <a:t>1</a:t>
+            </a:fld>
+            <a:endParaRPr kumimoji="0" lang="en-GB" sz="1200" b="0" i="0" u="none" strike="noStrike" kern="0" cap="none" spc="0" normalizeH="0" baseline="0" noProof="0" dirty="0">
+              <a:ln>
+                <a:noFill/>
+              </a:ln>
+              <a:solidFill>
+                <a:srgbClr val="000000"/>
+              </a:solidFill>
+              <a:effectLst/>
+              <a:uLnTx/>
+              <a:uFillTx/>
+              <a:latin typeface="Calibri"/>
+              <a:ea typeface="Calibri"/>
+              <a:cs typeface="Calibri"/>
+              <a:sym typeface="Calibri"/>
+            </a:endParaRPr>
+          </a:p>
+        </p:txBody>
+      </p:sp>
+    </p:spTree>
+    <p:extLst>
+      <p:ext uri="{BB962C8B-B14F-4D97-AF65-F5344CB8AC3E}">
+        <p14:creationId xmlns:p14="http://schemas.microsoft.com/office/powerpoint/2010/main" val="1733709011"/>
+      </p:ext>
+    </p:extLst>
+  </p:cSld>
+  <p:clrMapOvr>
+    <a:masterClrMapping/>
+  </p:clrMapOvr>
+</p:notes>
+</file>
+
+<file path=ppt/notesSlides/notesSlide2.xml><?xml version="1.0" encoding="utf-8"?>
+<p:notes xmlns:a="http://schemas.openxmlformats.org/drawingml/2006/main" xmlns:r="http://schemas.openxmlformats.org/officeDocument/2006/relationships" xmlns:p="http://schemas.openxmlformats.org/presentationml/2006/main">
+  <p:cSld>
+    <p:spTree>
+      <p:nvGrpSpPr>
+        <p:cNvPr id="1" name=""/>
+        <p:cNvGrpSpPr/>
+        <p:nvPr/>
+      </p:nvGrpSpPr>
+      <p:grpSpPr>
+        <a:xfrm>
+          <a:off x="0" y="0"/>
+          <a:ext cx="0" cy="0"/>
+          <a:chOff x="0" y="0"/>
+          <a:chExt cx="0" cy="0"/>
+        </a:xfrm>
+      </p:grpSpPr>
+      <p:sp>
+        <p:nvSpPr>
+          <p:cNvPr id="2" name="Slide Image Placeholder 1"/>
+          <p:cNvSpPr>
+            <a:spLocks noGrp="1" noRot="1" noChangeAspect="1"/>
+          </p:cNvSpPr>
+          <p:nvPr>
+            <p:ph type="sldImg"/>
+          </p:nvPr>
+        </p:nvSpPr>
+        <p:spPr/>
+      </p:sp>
+      <p:sp>
+        <p:nvSpPr>
+          <p:cNvPr id="3" name="Notes Placeholder 2"/>
+          <p:cNvSpPr>
+            <a:spLocks noGrp="1"/>
+          </p:cNvSpPr>
+          <p:nvPr>
+            <p:ph type="body" idx="1"/>
+          </p:nvPr>
+        </p:nvSpPr>
+        <p:spPr/>
+        <p:txBody>
+          <a:bodyPr/>
+          <a:lstStyle/>
+          <a:p>
             <a:endParaRPr lang="en-BE" dirty="0"/>
           </a:p>
         </p:txBody>
@@ -563,7 +731,181 @@
 </p:notes>
 </file>
 
-<file path=ppt/notesSlides/notesSlide2.xml><?xml version="1.0" encoding="utf-8"?>
+<file path=ppt/notesSlides/notesSlide3.xml><?xml version="1.0" encoding="utf-8"?>
+<p:notes xmlns:a="http://schemas.openxmlformats.org/drawingml/2006/main" xmlns:r="http://schemas.openxmlformats.org/officeDocument/2006/relationships" xmlns:p="http://schemas.openxmlformats.org/presentationml/2006/main">
+  <p:cSld>
+    <p:spTree>
+      <p:nvGrpSpPr>
+        <p:cNvPr id="1" name="">
+          <a:extLst>
+            <a:ext uri="{FF2B5EF4-FFF2-40B4-BE49-F238E27FC236}">
+              <a16:creationId xmlns:a16="http://schemas.microsoft.com/office/drawing/2014/main" id="{BD929EC3-8E50-0914-6B9A-76189787CB1D}"/>
+            </a:ext>
+          </a:extLst>
+        </p:cNvPr>
+        <p:cNvGrpSpPr/>
+        <p:nvPr/>
+      </p:nvGrpSpPr>
+      <p:grpSpPr>
+        <a:xfrm>
+          <a:off x="0" y="0"/>
+          <a:ext cx="0" cy="0"/>
+          <a:chOff x="0" y="0"/>
+          <a:chExt cx="0" cy="0"/>
+        </a:xfrm>
+      </p:grpSpPr>
+      <p:sp>
+        <p:nvSpPr>
+          <p:cNvPr id="2" name="Slide Image Placeholder 1">
+            <a:extLst>
+              <a:ext uri="{FF2B5EF4-FFF2-40B4-BE49-F238E27FC236}">
+                <a16:creationId xmlns:a16="http://schemas.microsoft.com/office/drawing/2014/main" id="{8C5AA56A-C86F-5378-F7C5-100A40A354A8}"/>
+              </a:ext>
+            </a:extLst>
+          </p:cNvPr>
+          <p:cNvSpPr>
+            <a:spLocks noGrp="1" noRot="1" noChangeAspect="1"/>
+          </p:cNvSpPr>
+          <p:nvPr>
+            <p:ph type="sldImg"/>
+          </p:nvPr>
+        </p:nvSpPr>
+        <p:spPr/>
+      </p:sp>
+      <p:sp>
+        <p:nvSpPr>
+          <p:cNvPr id="3" name="Notes Placeholder 2">
+            <a:extLst>
+              <a:ext uri="{FF2B5EF4-FFF2-40B4-BE49-F238E27FC236}">
+                <a16:creationId xmlns:a16="http://schemas.microsoft.com/office/drawing/2014/main" id="{02845911-23FB-06F0-0015-A59CA27C0BE5}"/>
+              </a:ext>
+            </a:extLst>
+          </p:cNvPr>
+          <p:cNvSpPr>
+            <a:spLocks noGrp="1"/>
+          </p:cNvSpPr>
+          <p:nvPr>
+            <p:ph type="body" idx="1"/>
+          </p:nvPr>
+        </p:nvSpPr>
+        <p:spPr/>
+        <p:txBody>
+          <a:bodyPr/>
+          <a:lstStyle/>
+          <a:p>
+            <a:endParaRPr lang="en-BE"/>
+          </a:p>
+        </p:txBody>
+      </p:sp>
+      <p:sp>
+        <p:nvSpPr>
+          <p:cNvPr id="4" name="Slide Number Placeholder 3">
+            <a:extLst>
+              <a:ext uri="{FF2B5EF4-FFF2-40B4-BE49-F238E27FC236}">
+                <a16:creationId xmlns:a16="http://schemas.microsoft.com/office/drawing/2014/main" id="{093E63F6-8119-C63B-7C93-5CD77CDAC5BB}"/>
+              </a:ext>
+            </a:extLst>
+          </p:cNvPr>
+          <p:cNvSpPr>
+            <a:spLocks noGrp="1"/>
+          </p:cNvSpPr>
+          <p:nvPr>
+            <p:ph type="sldNum" idx="12"/>
+          </p:nvPr>
+        </p:nvSpPr>
+        <p:spPr/>
+        <p:txBody>
+          <a:bodyPr/>
+          <a:lstStyle/>
+          <a:p>
+            <a:pPr marL="0" marR="0" lvl="0" indent="0" algn="r" defTabSz="914400" rtl="0" eaLnBrk="1" fontAlgn="auto" latinLnBrk="0" hangingPunct="1">
+              <a:lnSpc>
+                <a:spcPct val="100000"/>
+              </a:lnSpc>
+              <a:spcBef>
+                <a:spcPts val="0"/>
+              </a:spcBef>
+              <a:spcAft>
+                <a:spcPts val="0"/>
+              </a:spcAft>
+              <a:buClr>
+                <a:srgbClr val="000000"/>
+              </a:buClr>
+              <a:buSzPts val="1200"/>
+              <a:buFont typeface="Arial"/>
+              <a:buNone/>
+              <a:tabLst/>
+              <a:defRPr/>
+            </a:pPr>
+            <a:fld id="{00000000-1234-1234-1234-123412341234}" type="slidenum">
+              <a:rPr kumimoji="0" lang="en-GB" sz="1200" b="0" i="0" u="none" strike="noStrike" kern="0" cap="none" spc="0" normalizeH="0" baseline="0" noProof="0" smtClean="0">
+                <a:ln>
+                  <a:noFill/>
+                </a:ln>
+                <a:solidFill>
+                  <a:srgbClr val="000000"/>
+                </a:solidFill>
+                <a:effectLst/>
+                <a:uLnTx/>
+                <a:uFillTx/>
+                <a:latin typeface="Calibri"/>
+                <a:ea typeface="Calibri"/>
+                <a:cs typeface="Calibri"/>
+                <a:sym typeface="Calibri"/>
+              </a:rPr>
+              <a:pPr marL="0" marR="0" lvl="0" indent="0" algn="r" defTabSz="914400" rtl="0" eaLnBrk="1" fontAlgn="auto" latinLnBrk="0" hangingPunct="1">
+                <a:lnSpc>
+                  <a:spcPct val="100000"/>
+                </a:lnSpc>
+                <a:spcBef>
+                  <a:spcPts val="0"/>
+                </a:spcBef>
+                <a:spcAft>
+                  <a:spcPts val="0"/>
+                </a:spcAft>
+                <a:buClr>
+                  <a:srgbClr val="000000"/>
+                </a:buClr>
+                <a:buSzPts val="1200"/>
+                <a:buFont typeface="Arial"/>
+                <a:buNone/>
+                <a:tabLst/>
+                <a:defRPr/>
+              </a:pPr>
+              <a:t>4</a:t>
+            </a:fld>
+            <a:endParaRPr kumimoji="0" lang="en-GB" sz="1200" b="0" i="0" u="none" strike="noStrike" kern="0" cap="none" spc="0" normalizeH="0" baseline="0" noProof="0" dirty="0">
+              <a:ln>
+                <a:noFill/>
+              </a:ln>
+              <a:solidFill>
+                <a:srgbClr val="000000"/>
+              </a:solidFill>
+              <a:effectLst/>
+              <a:uLnTx/>
+              <a:uFillTx/>
+              <a:latin typeface="Calibri"/>
+              <a:ea typeface="Calibri"/>
+              <a:cs typeface="Calibri"/>
+              <a:sym typeface="Calibri"/>
+            </a:endParaRPr>
+          </a:p>
+        </p:txBody>
+      </p:sp>
+    </p:spTree>
+    <p:extLst>
+      <p:ext uri="{BB962C8B-B14F-4D97-AF65-F5344CB8AC3E}">
+        <p14:creationId xmlns:p14="http://schemas.microsoft.com/office/powerpoint/2010/main" val="718837463"/>
+      </p:ext>
+    </p:extLst>
+  </p:cSld>
+  <p:clrMapOvr>
+    <a:masterClrMapping/>
+  </p:clrMapOvr>
+</p:notes>
+</file>
+
+<file path=ppt/notesSlides/notesSlide4.xml><?xml version="1.0" encoding="utf-8"?>
 <p:notes xmlns:a="http://schemas.openxmlformats.org/drawingml/2006/main" xmlns:r="http://schemas.openxmlformats.org/officeDocument/2006/relationships" xmlns:p="http://schemas.openxmlformats.org/presentationml/2006/main">
   <p:cSld>
     <p:spTree>
@@ -628,7 +970,7 @@
           <a:p>
             <a:fld id="{DEEFEEDD-7AE0-2545-865B-4637248A80C7}" type="slidenum">
               <a:rPr lang="en-BE" smtClean="0"/>
-              <a:t>5</a:t>
+              <a:t>6</a:t>
             </a:fld>
             <a:endParaRPr lang="en-BE"/>
           </a:p>
@@ -647,7 +989,7 @@
 </p:notes>
 </file>
 
-<file path=ppt/notesSlides/notesSlide3.xml><?xml version="1.0" encoding="utf-8"?>
+<file path=ppt/notesSlides/notesSlide5.xml><?xml version="1.0" encoding="utf-8"?>
 <p:notes xmlns:a="http://schemas.openxmlformats.org/drawingml/2006/main" xmlns:r="http://schemas.openxmlformats.org/officeDocument/2006/relationships" xmlns:p="http://schemas.openxmlformats.org/presentationml/2006/main">
   <p:cSld>
     <p:spTree>
@@ -788,7 +1130,7 @@
                 <a:tabLst/>
                 <a:defRPr/>
               </a:pPr>
-              <a:t>7</a:t>
+              <a:t>8</a:t>
             </a:fld>
             <a:endParaRPr kumimoji="0" lang="en-GB" sz="1200" b="0" i="0" u="none" strike="noStrike" kern="0" cap="none" spc="0" normalizeH="0" baseline="0" noProof="0" dirty="0">
               <a:ln>
@@ -952,7 +1294,7 @@
           <a:p>
             <a:fld id="{6DF6E040-B977-3E44-A5D5-1DB941796BBD}" type="datetimeFigureOut">
               <a:rPr lang="en-BE" smtClean="0"/>
-              <a:t>12/19/25</a:t>
+              <a:t>4/4/26</a:t>
             </a:fld>
             <a:endParaRPr lang="en-BE"/>
           </a:p>
@@ -1122,7 +1464,7 @@
           <a:p>
             <a:fld id="{6DF6E040-B977-3E44-A5D5-1DB941796BBD}" type="datetimeFigureOut">
               <a:rPr lang="en-BE" smtClean="0"/>
-              <a:t>12/19/25</a:t>
+              <a:t>4/4/26</a:t>
             </a:fld>
             <a:endParaRPr lang="en-BE"/>
           </a:p>
@@ -1302,7 +1644,7 @@
           <a:p>
             <a:fld id="{6DF6E040-B977-3E44-A5D5-1DB941796BBD}" type="datetimeFigureOut">
               <a:rPr lang="en-BE" smtClean="0"/>
-              <a:t>12/19/25</a:t>
+              <a:t>4/4/26</a:t>
             </a:fld>
             <a:endParaRPr lang="en-BE"/>
           </a:p>
@@ -1472,7 +1814,7 @@
           <a:p>
             <a:fld id="{6DF6E040-B977-3E44-A5D5-1DB941796BBD}" type="datetimeFigureOut">
               <a:rPr lang="en-BE" smtClean="0"/>
-              <a:t>12/19/25</a:t>
+              <a:t>4/4/26</a:t>
             </a:fld>
             <a:endParaRPr lang="en-BE"/>
           </a:p>
@@ -1718,7 +2060,7 @@
           <a:p>
             <a:fld id="{6DF6E040-B977-3E44-A5D5-1DB941796BBD}" type="datetimeFigureOut">
               <a:rPr lang="en-BE" smtClean="0"/>
-              <a:t>12/19/25</a:t>
+              <a:t>4/4/26</a:t>
             </a:fld>
             <a:endParaRPr lang="en-BE"/>
           </a:p>
@@ -1950,7 +2292,7 @@
           <a:p>
             <a:fld id="{6DF6E040-B977-3E44-A5D5-1DB941796BBD}" type="datetimeFigureOut">
               <a:rPr lang="en-BE" smtClean="0"/>
-              <a:t>12/19/25</a:t>
+              <a:t>4/4/26</a:t>
             </a:fld>
             <a:endParaRPr lang="en-BE"/>
           </a:p>
@@ -2317,7 +2659,7 @@
           <a:p>
             <a:fld id="{6DF6E040-B977-3E44-A5D5-1DB941796BBD}" type="datetimeFigureOut">
               <a:rPr lang="en-BE" smtClean="0"/>
-              <a:t>12/19/25</a:t>
+              <a:t>4/4/26</a:t>
             </a:fld>
             <a:endParaRPr lang="en-BE"/>
           </a:p>
@@ -2435,7 +2777,7 @@
           <a:p>
             <a:fld id="{6DF6E040-B977-3E44-A5D5-1DB941796BBD}" type="datetimeFigureOut">
               <a:rPr lang="en-BE" smtClean="0"/>
-              <a:t>12/19/25</a:t>
+              <a:t>4/4/26</a:t>
             </a:fld>
             <a:endParaRPr lang="en-BE"/>
           </a:p>
@@ -2530,7 +2872,7 @@
           <a:p>
             <a:fld id="{6DF6E040-B977-3E44-A5D5-1DB941796BBD}" type="datetimeFigureOut">
               <a:rPr lang="en-BE" smtClean="0"/>
-              <a:t>12/19/25</a:t>
+              <a:t>4/4/26</a:t>
             </a:fld>
             <a:endParaRPr lang="en-BE"/>
           </a:p>
@@ -2807,7 +3149,7 @@
           <a:p>
             <a:fld id="{6DF6E040-B977-3E44-A5D5-1DB941796BBD}" type="datetimeFigureOut">
               <a:rPr lang="en-BE" smtClean="0"/>
-              <a:t>12/19/25</a:t>
+              <a:t>4/4/26</a:t>
             </a:fld>
             <a:endParaRPr lang="en-BE"/>
           </a:p>
@@ -3064,7 +3406,7 @@
           <a:p>
             <a:fld id="{6DF6E040-B977-3E44-A5D5-1DB941796BBD}" type="datetimeFigureOut">
               <a:rPr lang="en-BE" smtClean="0"/>
-              <a:t>12/19/25</a:t>
+              <a:t>4/4/26</a:t>
             </a:fld>
             <a:endParaRPr lang="en-BE"/>
           </a:p>
@@ -3286,7 +3628,7 @@
           <a:p>
             <a:fld id="{6DF6E040-B977-3E44-A5D5-1DB941796BBD}" type="datetimeFigureOut">
               <a:rPr lang="en-BE" smtClean="0"/>
-              <a:t>12/19/25</a:t>
+              <a:t>4/4/26</a:t>
             </a:fld>
             <a:endParaRPr lang="en-BE"/>
           </a:p>
@@ -3693,87 +4035,285 @@
       </p:grpSpPr>
       <p:sp>
         <p:nvSpPr>
-          <p:cNvPr id="2" name="ISDA Church Name">
+          <p:cNvPr id="4" name="TextBox 3">
             <a:extLst>
               <a:ext uri="{FF2B5EF4-FFF2-40B4-BE49-F238E27FC236}">
-                <a16:creationId xmlns:a16="http://schemas.microsoft.com/office/drawing/2014/main" id="{D74394BE-5824-CEC3-DFF6-C9A1CE07F892}"/>
+                <a16:creationId xmlns:a16="http://schemas.microsoft.com/office/drawing/2014/main" id="{E4EABF2B-F41D-ECA0-0FB6-5F20262E776A}"/>
               </a:ext>
             </a:extLst>
           </p:cNvPr>
-          <p:cNvSpPr/>
+          <p:cNvSpPr txBox="1"/>
           <p:nvPr/>
         </p:nvSpPr>
         <p:spPr>
           <a:xfrm>
-            <a:off x="2701693" y="2915494"/>
-            <a:ext cx="6788614" cy="1928355"/>
+            <a:off x="680847" y="525288"/>
+            <a:ext cx="6832198" cy="3970115"/>
+          </a:xfrm>
+          <a:prstGeom prst="rect">
+            <a:avLst/>
+          </a:prstGeom>
+        </p:spPr>
+        <p:txBody>
+          <a:bodyPr vert="horz" lIns="91440" tIns="45720" rIns="91440" bIns="45720" rtlCol="0" anchor="b">
+            <a:noAutofit/>
+          </a:bodyPr>
+          <a:lstStyle/>
+          <a:p>
+            <a:pPr marL="0" marR="0" lvl="0" indent="0" algn="l" defTabSz="914400" rtl="0" eaLnBrk="1" fontAlgn="auto" latinLnBrk="0" hangingPunct="1">
+              <a:lnSpc>
+                <a:spcPct val="90000"/>
+              </a:lnSpc>
+              <a:spcBef>
+                <a:spcPct val="0"/>
+              </a:spcBef>
+              <a:spcAft>
+                <a:spcPts val="600"/>
+              </a:spcAft>
+              <a:buClr>
+                <a:srgbClr val="000000"/>
+              </a:buClr>
+              <a:buSzTx/>
+              <a:buFont typeface="Arial"/>
+              <a:buNone/>
+              <a:tabLst/>
+              <a:defRPr/>
+            </a:pPr>
+            <a:r>
+              <a:rPr kumimoji="0" lang="en-US" sz="5400" b="1" u="none" strike="noStrike" kern="1200" cap="none" spc="0" normalizeH="0" baseline="0" noProof="0" dirty="0">
+                <a:solidFill>
+                  <a:schemeClr val="bg2">
+                    <a:lumMod val="25000"/>
+                    <a:lumOff val="75000"/>
+                  </a:schemeClr>
+                </a:solidFill>
+                <a:effectLst/>
+                <a:uLnTx/>
+                <a:uFillTx/>
+                <a:latin typeface="Nunito ExtraBold" pitchFamily="2" charset="77"/>
+                <a:cs typeface="Arial"/>
+                <a:sym typeface="Arial"/>
+              </a:rPr>
+              <a:t>BRUSSELS INTERNATIONAL </a:t>
+            </a:r>
+            <a:r>
+              <a:rPr kumimoji="0" lang="en-US" sz="5400" b="1" u="none" strike="noStrike" kern="1200" cap="none" spc="0" normalizeH="0" baseline="0" noProof="0" dirty="0">
+                <a:solidFill>
+                  <a:schemeClr val="bg2">
+                    <a:lumMod val="10000"/>
+                    <a:lumOff val="90000"/>
+                  </a:schemeClr>
+                </a:solidFill>
+                <a:effectLst/>
+                <a:uLnTx/>
+                <a:uFillTx/>
+                <a:latin typeface="Nunito ExtraBold" pitchFamily="2" charset="77"/>
+                <a:cs typeface="Arial"/>
+                <a:sym typeface="Arial"/>
+              </a:rPr>
+              <a:t>SEVENTH DAY ADVENTIST CHURCH </a:t>
+            </a:r>
+          </a:p>
+        </p:txBody>
+      </p:sp>
+      <p:sp>
+        <p:nvSpPr>
+          <p:cNvPr id="5" name="TextBox 4">
+            <a:extLst>
+              <a:ext uri="{FF2B5EF4-FFF2-40B4-BE49-F238E27FC236}">
+                <a16:creationId xmlns:a16="http://schemas.microsoft.com/office/drawing/2014/main" id="{BB80DF60-B11C-9608-A6E5-910DAA70552C}"/>
+              </a:ext>
+            </a:extLst>
+          </p:cNvPr>
+          <p:cNvSpPr txBox="1"/>
+          <p:nvPr/>
+        </p:nvSpPr>
+        <p:spPr>
+          <a:xfrm>
+            <a:off x="680847" y="5755854"/>
+            <a:ext cx="5225142" cy="584775"/>
           </a:xfrm>
           <a:prstGeom prst="rect">
             <a:avLst/>
           </a:prstGeom>
           <a:noFill/>
-          <a:ln>
-            <a:noFill/>
-          </a:ln>
         </p:spPr>
-        <p:style>
-          <a:lnRef idx="2">
-            <a:schemeClr val="accent1">
-              <a:shade val="15000"/>
-            </a:schemeClr>
-          </a:lnRef>
-          <a:fillRef idx="1">
-            <a:schemeClr val="accent1"/>
-          </a:fillRef>
-          <a:effectRef idx="0">
-            <a:schemeClr val="accent1"/>
-          </a:effectRef>
-          <a:fontRef idx="minor">
-            <a:schemeClr val="lt1"/>
-          </a:fontRef>
-        </p:style>
         <p:txBody>
-          <a:bodyPr rtlCol="0" anchor="ctr"/>
+          <a:bodyPr wrap="square" rtlCol="0">
+            <a:spAutoFit/>
+          </a:bodyPr>
           <a:lstStyle/>
           <a:p>
-            <a:pPr algn="ctr"/>
+            <a:pPr marL="0" marR="0" lvl="0" indent="0" algn="l" defTabSz="914400" rtl="0" eaLnBrk="1" fontAlgn="auto" latinLnBrk="0" hangingPunct="1">
+              <a:lnSpc>
+                <a:spcPct val="100000"/>
+              </a:lnSpc>
+              <a:spcBef>
+                <a:spcPts val="0"/>
+              </a:spcBef>
+              <a:spcAft>
+                <a:spcPts val="0"/>
+              </a:spcAft>
+              <a:buClr>
+                <a:srgbClr val="000000"/>
+              </a:buClr>
+              <a:buSzTx/>
+              <a:buFont typeface="Arial"/>
+              <a:buNone/>
+              <a:tabLst/>
+              <a:defRPr/>
+            </a:pPr>
             <a:r>
-              <a:rPr lang="en-BE" sz="4400" b="1" dirty="0">
+              <a:rPr kumimoji="0" lang="en-BE" sz="3200" b="1" u="none" strike="noStrike" kern="1200" cap="none" spc="0" normalizeH="0" baseline="0" noProof="0">
+                <a:ln>
+                  <a:noFill/>
+                </a:ln>
                 <a:solidFill>
-                  <a:schemeClr val="tx2">
-                    <a:lumMod val="25000"/>
-                    <a:lumOff val="75000"/>
-                  </a:schemeClr>
+                  <a:srgbClr val="FFFFFF"/>
+                </a:solidFill>
+                <a:effectLst/>
+                <a:uLnTx/>
+                <a:uFillTx/>
+                <a:latin typeface="Nunito ExtraBold" pitchFamily="2" charset="77"/>
+                <a:ea typeface="Noto Sans Light" panose="020B0402040504020204" pitchFamily="34" charset="0"/>
+                <a:cs typeface="Noto Sans Light" panose="020B0402040504020204" pitchFamily="34" charset="0"/>
+                <a:sym typeface="Arial"/>
+              </a:rPr>
+              <a:t>S</a:t>
+            </a:r>
+            <a:r>
+              <a:rPr kumimoji="0" lang="en-US" sz="3200" b="1" u="none" strike="noStrike" kern="1200" cap="none" spc="0" normalizeH="0" baseline="0" noProof="0" dirty="0">
+                <a:ln>
+                  <a:noFill/>
+                </a:ln>
+                <a:solidFill>
+                  <a:srgbClr val="FFFFFF"/>
+                </a:solidFill>
+                <a:effectLst/>
+                <a:uLnTx/>
+                <a:uFillTx/>
+                <a:latin typeface="Nunito ExtraBold" pitchFamily="2" charset="77"/>
+                <a:ea typeface="Noto Sans Light" panose="020B0402040504020204" pitchFamily="34" charset="0"/>
+                <a:cs typeface="Noto Sans Light" panose="020B0402040504020204" pitchFamily="34" charset="0"/>
+                <a:sym typeface="Arial"/>
+              </a:rPr>
+              <a:t>t</a:t>
+            </a:r>
+            <a:r>
+              <a:rPr kumimoji="0" lang="en-BE" sz="3200" b="1" u="none" strike="noStrike" kern="1200" cap="none" spc="0" normalizeH="0" baseline="0" noProof="0">
+                <a:ln>
+                  <a:noFill/>
+                </a:ln>
+                <a:solidFill>
+                  <a:srgbClr val="FFFFFF"/>
+                </a:solidFill>
+                <a:effectLst/>
+                <a:uLnTx/>
+                <a:uFillTx/>
+                <a:latin typeface="Nunito ExtraBold" pitchFamily="2" charset="77"/>
+                <a:ea typeface="Noto Sans Light" panose="020B0402040504020204" pitchFamily="34" charset="0"/>
+                <a:cs typeface="Noto Sans Light" panose="020B0402040504020204" pitchFamily="34" charset="0"/>
+                <a:sym typeface="Arial"/>
+              </a:rPr>
+              <a:t>arting at 10:45 am</a:t>
+            </a:r>
+          </a:p>
+        </p:txBody>
+      </p:sp>
+      <p:sp>
+        <p:nvSpPr>
+          <p:cNvPr id="6" name="TextBox 5">
+            <a:extLst>
+              <a:ext uri="{FF2B5EF4-FFF2-40B4-BE49-F238E27FC236}">
+                <a16:creationId xmlns:a16="http://schemas.microsoft.com/office/drawing/2014/main" id="{EA485C30-3470-66E3-759D-FD5C090CF1FA}"/>
+              </a:ext>
+            </a:extLst>
+          </p:cNvPr>
+          <p:cNvSpPr txBox="1"/>
+          <p:nvPr/>
+        </p:nvSpPr>
+        <p:spPr>
+          <a:xfrm>
+            <a:off x="5783371" y="5755854"/>
+            <a:ext cx="5727782" cy="584775"/>
+          </a:xfrm>
+          <a:prstGeom prst="rect">
+            <a:avLst/>
+          </a:prstGeom>
+          <a:noFill/>
+        </p:spPr>
+        <p:txBody>
+          <a:bodyPr wrap="square" rtlCol="0">
+            <a:spAutoFit/>
+          </a:bodyPr>
+          <a:lstStyle/>
+          <a:p>
+            <a:pPr lvl="0" algn="r">
+              <a:buClr>
+                <a:srgbClr val="000000"/>
+              </a:buClr>
+              <a:defRPr/>
+            </a:pPr>
+            <a:r>
+              <a:rPr lang="en-GB" sz="3200" b="1" dirty="0">
+                <a:solidFill>
+                  <a:srgbClr val="FFFFFF"/>
                 </a:solidFill>
                 <a:latin typeface="Nunito ExtraBold" pitchFamily="2" charset="77"/>
-                <a:ea typeface="Change" pitchFamily="2" charset="0"/>
-                <a:cs typeface="Modak" pitchFamily="2" charset="77"/>
+                <a:ea typeface="Noto Sans ExtraLight" panose="020B0302040504020204" pitchFamily="34" charset="0"/>
+                <a:cs typeface="Noto Sans ExtraLight" panose="020B0302040504020204" pitchFamily="34" charset="0"/>
+                <a:sym typeface="Arial"/>
               </a:rPr>
-              <a:t>Brussels International </a:t>
+              <a:t>24</a:t>
             </a:r>
             <a:r>
-              <a:rPr lang="en-BE" sz="4400" b="1" dirty="0">
+              <a:rPr lang="en-GB" sz="3200" b="1" baseline="30000" dirty="0">
                 <a:solidFill>
-                  <a:schemeClr val="tx2">
-                    <a:lumMod val="10000"/>
-                    <a:lumOff val="90000"/>
-                  </a:schemeClr>
+                  <a:srgbClr val="FFFFFF"/>
                 </a:solidFill>
                 <a:latin typeface="Nunito ExtraBold" pitchFamily="2" charset="77"/>
-                <a:ea typeface="Change" pitchFamily="2" charset="0"/>
-                <a:cs typeface="Modak" pitchFamily="2" charset="77"/>
+                <a:ea typeface="Noto Sans ExtraLight" panose="020B0302040504020204" pitchFamily="34" charset="0"/>
+                <a:cs typeface="Noto Sans ExtraLight" panose="020B0302040504020204" pitchFamily="34" charset="0"/>
+                <a:sym typeface="Arial"/>
               </a:rPr>
-              <a:t>Seventh Day Adventist Church</a:t>
+              <a:t>th</a:t>
             </a:r>
+            <a:r>
+              <a:rPr lang="en-GB" sz="3200" b="1" dirty="0">
+                <a:solidFill>
+                  <a:srgbClr val="FFFFFF"/>
+                </a:solidFill>
+                <a:latin typeface="Nunito ExtraBold" pitchFamily="2" charset="77"/>
+                <a:ea typeface="Noto Sans ExtraLight" panose="020B0302040504020204" pitchFamily="34" charset="0"/>
+                <a:cs typeface="Noto Sans ExtraLight" panose="020B0302040504020204" pitchFamily="34" charset="0"/>
+                <a:sym typeface="Arial"/>
+              </a:rPr>
+              <a:t> January 2026</a:t>
+            </a:r>
+            <a:endParaRPr kumimoji="0" lang="en-BE" sz="3200" b="1" u="none" strike="noStrike" kern="1200" cap="none" spc="0" normalizeH="0" baseline="0" noProof="0" dirty="0">
+              <a:ln>
+                <a:noFill/>
+              </a:ln>
+              <a:solidFill>
+                <a:srgbClr val="FFFFFF"/>
+              </a:solidFill>
+              <a:effectLst/>
+              <a:uLnTx/>
+              <a:uFillTx/>
+              <a:latin typeface="Nunito ExtraBold" pitchFamily="2" charset="77"/>
+              <a:ea typeface="Noto Sans ExtraLight" panose="020B0302040504020204" pitchFamily="34" charset="0"/>
+              <a:cs typeface="Noto Sans ExtraLight" panose="020B0302040504020204" pitchFamily="34" charset="0"/>
+              <a:sym typeface="Arial"/>
+            </a:endParaRPr>
           </a:p>
         </p:txBody>
       </p:sp>
       <p:pic>
         <p:nvPicPr>
-          <p:cNvPr id="3" name="Logo" descr="A logo with wings and a blue circle&#10;&#10;Description automatically generated">
+          <p:cNvPr id="3" name="Picture 2">
             <a:extLst>
               <a:ext uri="{FF2B5EF4-FFF2-40B4-BE49-F238E27FC236}">
-                <a16:creationId xmlns:a16="http://schemas.microsoft.com/office/drawing/2014/main" id="{EEC184F2-33E7-E5EB-2E29-311979453635}"/>
+                <a16:creationId xmlns:a16="http://schemas.microsoft.com/office/drawing/2014/main" id="{4B8817C9-F47E-9C65-129F-E6F419C06C2D}"/>
               </a:ext>
             </a:extLst>
           </p:cNvPr>
@@ -3783,15 +4323,20 @@
           <p:nvPr/>
         </p:nvPicPr>
         <p:blipFill>
-          <a:blip r:embed="rId2"/>
-          <a:stretch>
-            <a:fillRect/>
-          </a:stretch>
+          <a:blip r:embed="rId3">
+            <a:extLst>
+              <a:ext uri="{28A0092B-C50C-407E-A947-70E740481C1C}">
+                <a14:useLocalDpi xmlns:a14="http://schemas.microsoft.com/office/drawing/2010/main" val="0"/>
+              </a:ext>
+            </a:extLst>
+          </a:blip>
+          <a:srcRect/>
+          <a:stretch/>
         </p:blipFill>
         <p:spPr>
           <a:xfrm>
-            <a:off x="5482281" y="1342067"/>
-            <a:ext cx="1227438" cy="1227438"/>
+            <a:off x="8247092" y="878314"/>
+            <a:ext cx="3264061" cy="3264061"/>
           </a:xfrm>
           <a:prstGeom prst="rect">
             <a:avLst/>
@@ -3801,7 +4346,7 @@
     </p:spTree>
     <p:extLst>
       <p:ext uri="{BB962C8B-B14F-4D97-AF65-F5344CB8AC3E}">
-        <p14:creationId xmlns:p14="http://schemas.microsoft.com/office/powerpoint/2010/main" val="1985050468"/>
+        <p14:creationId xmlns:p14="http://schemas.microsoft.com/office/powerpoint/2010/main" val="429454083"/>
       </p:ext>
     </p:extLst>
   </p:cSld>
@@ -3842,11 +4387,13 @@
         </p:nvSpPr>
         <p:spPr>
           <a:xfrm>
-            <a:off x="4148193" y="130649"/>
-            <a:ext cx="3895618" cy="584775"/>
+            <a:off x="9358811" y="177973"/>
+            <a:ext cx="2652916" cy="422713"/>
           </a:xfrm>
-          <a:prstGeom prst="rect">
-            <a:avLst/>
+          <a:prstGeom prst="roundRect">
+            <a:avLst>
+              <a:gd name="adj" fmla="val 50000"/>
+            </a:avLst>
           </a:prstGeom>
           <a:solidFill>
             <a:schemeClr val="bg1"/>
@@ -3877,9 +4424,9 @@
           </a:bodyPr>
           <a:lstStyle/>
           <a:p>
-            <a:pPr algn="ctr"/>
+            <a:pPr algn="r"/>
             <a:r>
-              <a:rPr lang="en-BE" sz="3200" b="1" dirty="0">
+              <a:rPr lang="en-BE" sz="2000" b="1" dirty="0">
                 <a:solidFill>
                   <a:schemeClr val="tx1"/>
                 </a:solidFill>
@@ -3887,8 +4434,27 @@
                 <a:ea typeface="Change" pitchFamily="2" charset="0"/>
                 <a:cs typeface="Modak" pitchFamily="2" charset="77"/>
               </a:rPr>
-              <a:t>Media with caption</a:t>
+              <a:t>Media </a:t>
             </a:r>
+            <a:r>
+              <a:rPr lang="en-BE" sz="2000" b="1">
+                <a:solidFill>
+                  <a:schemeClr val="tx1"/>
+                </a:solidFill>
+                <a:latin typeface="Nunito ExtraBold" pitchFamily="2" charset="77"/>
+                <a:ea typeface="Change" pitchFamily="2" charset="0"/>
+                <a:cs typeface="Modak" pitchFamily="2" charset="77"/>
+              </a:rPr>
+              <a:t>with caption</a:t>
+            </a:r>
+            <a:endParaRPr lang="en-BE" sz="2000" b="1" dirty="0">
+              <a:solidFill>
+                <a:schemeClr val="tx1"/>
+              </a:solidFill>
+              <a:latin typeface="Nunito ExtraBold" pitchFamily="2" charset="77"/>
+              <a:ea typeface="Change" pitchFamily="2" charset="0"/>
+              <a:cs typeface="Modak" pitchFamily="2" charset="77"/>
+            </a:endParaRPr>
           </a:p>
         </p:txBody>
       </p:sp>
@@ -4002,6 +4568,144 @@
   <p:cSld>
     <p:spTree>
       <p:nvGrpSpPr>
+        <p:cNvPr id="1" name="">
+          <a:extLst>
+            <a:ext uri="{FF2B5EF4-FFF2-40B4-BE49-F238E27FC236}">
+              <a16:creationId xmlns:a16="http://schemas.microsoft.com/office/drawing/2014/main" id="{C6BC2485-0717-8D32-1019-4928F2379922}"/>
+            </a:ext>
+          </a:extLst>
+        </p:cNvPr>
+        <p:cNvGrpSpPr/>
+        <p:nvPr/>
+      </p:nvGrpSpPr>
+      <p:grpSpPr>
+        <a:xfrm>
+          <a:off x="0" y="0"/>
+          <a:ext cx="0" cy="0"/>
+          <a:chOff x="0" y="0"/>
+          <a:chExt cx="0" cy="0"/>
+        </a:xfrm>
+      </p:grpSpPr>
+      <p:sp>
+        <p:nvSpPr>
+          <p:cNvPr id="4" name="Title">
+            <a:extLst>
+              <a:ext uri="{FF2B5EF4-FFF2-40B4-BE49-F238E27FC236}">
+                <a16:creationId xmlns:a16="http://schemas.microsoft.com/office/drawing/2014/main" id="{074A4EF1-0AC4-7BAD-1880-AF59671ABCC1}"/>
+              </a:ext>
+            </a:extLst>
+          </p:cNvPr>
+          <p:cNvSpPr txBox="1"/>
+          <p:nvPr/>
+        </p:nvSpPr>
+        <p:spPr>
+          <a:xfrm>
+            <a:off x="735710" y="1443941"/>
+            <a:ext cx="7566245" cy="3970115"/>
+          </a:xfrm>
+          <a:prstGeom prst="rect">
+            <a:avLst/>
+          </a:prstGeom>
+        </p:spPr>
+        <p:txBody>
+          <a:bodyPr vert="horz" lIns="91440" tIns="45720" rIns="91440" bIns="45720" rtlCol="0" anchor="ctr">
+            <a:noAutofit/>
+          </a:bodyPr>
+          <a:lstStyle/>
+          <a:p>
+            <a:pPr marL="0" marR="0" lvl="0" indent="0" algn="l" defTabSz="914400" rtl="0" eaLnBrk="1" fontAlgn="auto" latinLnBrk="0" hangingPunct="1">
+              <a:lnSpc>
+                <a:spcPct val="90000"/>
+              </a:lnSpc>
+              <a:spcBef>
+                <a:spcPct val="0"/>
+              </a:spcBef>
+              <a:spcAft>
+                <a:spcPts val="600"/>
+              </a:spcAft>
+              <a:buClr>
+                <a:srgbClr val="000000"/>
+              </a:buClr>
+              <a:buSzTx/>
+              <a:buFontTx/>
+              <a:buNone/>
+              <a:tabLst/>
+              <a:defRPr/>
+            </a:pPr>
+            <a:r>
+              <a:rPr kumimoji="0" lang="en-GB" sz="6600" b="1" i="0" u="none" strike="noStrike" kern="1200" cap="none" spc="0" normalizeH="0" baseline="0" noProof="0" dirty="0">
+                <a:ln>
+                  <a:noFill/>
+                </a:ln>
+                <a:solidFill>
+                  <a:prstClr val="white"/>
+                </a:solidFill>
+                <a:effectLst/>
+                <a:uLnTx/>
+                <a:uFillTx/>
+                <a:latin typeface="Nunito ExtraBold" pitchFamily="2" charset="77"/>
+                <a:ea typeface="+mn-ea"/>
+                <a:cs typeface="Arial"/>
+                <a:sym typeface="Arial"/>
+              </a:rPr>
+              <a:t>Title with logo</a:t>
+            </a:r>
+          </a:p>
+        </p:txBody>
+      </p:sp>
+      <p:pic>
+        <p:nvPicPr>
+          <p:cNvPr id="3" name="Logo">
+            <a:extLst>
+              <a:ext uri="{FF2B5EF4-FFF2-40B4-BE49-F238E27FC236}">
+                <a16:creationId xmlns:a16="http://schemas.microsoft.com/office/drawing/2014/main" id="{45562F14-617D-DBFA-E2E8-F01177F7FDE0}"/>
+              </a:ext>
+            </a:extLst>
+          </p:cNvPr>
+          <p:cNvPicPr>
+            <a:picLocks noChangeAspect="1"/>
+          </p:cNvPicPr>
+          <p:nvPr/>
+        </p:nvPicPr>
+        <p:blipFill>
+          <a:blip r:embed="rId3">
+            <a:extLst>
+              <a:ext uri="{28A0092B-C50C-407E-A947-70E740481C1C}">
+                <a14:useLocalDpi xmlns:a14="http://schemas.microsoft.com/office/drawing/2010/main" val="0"/>
+              </a:ext>
+            </a:extLst>
+          </a:blip>
+          <a:srcRect/>
+          <a:stretch/>
+        </p:blipFill>
+        <p:spPr>
+          <a:xfrm>
+            <a:off x="8301955" y="1803293"/>
+            <a:ext cx="3264061" cy="3251409"/>
+          </a:xfrm>
+          <a:prstGeom prst="rect">
+            <a:avLst/>
+          </a:prstGeom>
+        </p:spPr>
+      </p:pic>
+    </p:spTree>
+    <p:extLst>
+      <p:ext uri="{BB962C8B-B14F-4D97-AF65-F5344CB8AC3E}">
+        <p14:creationId xmlns:p14="http://schemas.microsoft.com/office/powerpoint/2010/main" val="1362842086"/>
+      </p:ext>
+    </p:extLst>
+  </p:cSld>
+  <p:clrMapOvr>
+    <a:masterClrMapping/>
+  </p:clrMapOvr>
+</p:sld>
+</file>
+
+<file path=ppt/slides/slide5.xml><?xml version="1.0" encoding="utf-8"?>
+<p:sld xmlns:a="http://schemas.openxmlformats.org/drawingml/2006/main" xmlns:r="http://schemas.openxmlformats.org/officeDocument/2006/relationships" xmlns:p="http://schemas.openxmlformats.org/presentationml/2006/main">
+  <p:cSld>
+    <p:spTree>
+      <p:nvGrpSpPr>
         <p:cNvPr id="1" name=""/>
         <p:cNvGrpSpPr/>
         <p:nvPr/>
@@ -4103,7 +4807,7 @@
 </p:sld>
 </file>
 
-<file path=ppt/slides/slide5.xml><?xml version="1.0" encoding="utf-8"?>
+<file path=ppt/slides/slide6.xml><?xml version="1.0" encoding="utf-8"?>
 <p:sld xmlns:a="http://schemas.openxmlformats.org/drawingml/2006/main" xmlns:r="http://schemas.openxmlformats.org/officeDocument/2006/relationships" xmlns:p="http://schemas.openxmlformats.org/presentationml/2006/main">
   <p:cSld>
     <p:spTree>
@@ -4271,7 +4975,7 @@
 </p:sld>
 </file>
 
-<file path=ppt/slides/slide6.xml><?xml version="1.0" encoding="utf-8"?>
+<file path=ppt/slides/slide7.xml><?xml version="1.0" encoding="utf-8"?>
 <p:sld xmlns:a="http://schemas.openxmlformats.org/drawingml/2006/main" xmlns:r="http://schemas.openxmlformats.org/officeDocument/2006/relationships" xmlns:p="http://schemas.openxmlformats.org/presentationml/2006/main">
   <p:cSld>
     <p:spTree>
@@ -4471,7 +5175,7 @@
 </p:sld>
 </file>
 
-<file path=ppt/slides/slide7.xml><?xml version="1.0" encoding="utf-8"?>
+<file path=ppt/slides/slide8.xml><?xml version="1.0" encoding="utf-8"?>
 <p:sld xmlns:a="http://schemas.openxmlformats.org/drawingml/2006/main" xmlns:r="http://schemas.openxmlformats.org/officeDocument/2006/relationships" xmlns:p="http://schemas.openxmlformats.org/presentationml/2006/main">
   <p:cSld>
     <p:spTree>
@@ -4496,7 +5200,7 @@
       </p:grpSpPr>
       <p:pic>
         <p:nvPicPr>
-          <p:cNvPr id="3" name="Logo" descr="A logo with wings and a blue circle&#10;&#10;Description automatically generated">
+          <p:cNvPr id="3" name="Logo">
             <a:extLst>
               <a:ext uri="{FF2B5EF4-FFF2-40B4-BE49-F238E27FC236}">
                 <a16:creationId xmlns:a16="http://schemas.microsoft.com/office/drawing/2014/main" id="{6F64EB4C-E152-1891-7A68-955BA57FE92C}"/>
@@ -4509,16 +5213,9 @@
           <p:nvPr/>
         </p:nvPicPr>
         <p:blipFill>
-          <a:blip r:embed="rId3">
-            <a:extLst>
-              <a:ext uri="{28A0092B-C50C-407E-A947-70E740481C1C}">
-                <a14:useLocalDpi xmlns:a14="http://schemas.microsoft.com/office/drawing/2010/main" val="0"/>
-              </a:ext>
-            </a:extLst>
-          </a:blip>
-          <a:stretch>
-            <a:fillRect/>
-          </a:stretch>
+          <a:blip r:embed="rId3"/>
+          <a:srcRect/>
+          <a:stretch/>
         </p:blipFill>
         <p:spPr>
           <a:xfrm>

</xml_diff>